<commit_message>
Update python and ppt files from Day 4 to Day 21 with student and mentor details
</commit_message>
<xml_diff>
--- a/WEEK_2_Day_9_Mentor_Review.pptx
+++ b/WEEK_2_Day_9_Mentor_Review.pptx
@@ -3176,6 +3176,44 @@
             </a:pPr>
             <a:r>
               <a:t>  • Plot this mean intensity over time (frames) to visualize the raw physical OOK signal.</a:t>
+            </a:r>
+          </a:p>
+        </p:txBody>
+      </p:sp>
+      <p:sp>
+        <p:nvSpPr>
+          <p:cNvPr id="4" name="TextBox 3"/>
+          <p:cNvSpPr txBox="1"/>
+          <p:nvPr/>
+        </p:nvSpPr>
+        <p:spPr>
+          <a:xfrm>
+            <a:off x="457200" y="182880"/>
+            <a:ext cx="4572000" cy="914400"/>
+          </a:xfrm>
+          <a:prstGeom prst="rect">
+            <a:avLst/>
+          </a:prstGeom>
+          <a:noFill/>
+        </p:spPr>
+        <p:txBody>
+          <a:bodyPr wrap="none">
+            <a:spAutoFit/>
+          </a:bodyPr>
+          <a:lstStyle/>
+          <a:p>
+            <a:r>
+              <a:t>Name: K.Santhosh Reddy</a:t>
+            </a:r>
+          </a:p>
+          <a:p>
+            <a:r>
+              <a:t>Cohort: 4 Batch A2</a:t>
+            </a:r>
+          </a:p>
+          <a:p>
+            <a:r>
+              <a:t>Mentor: Mr. Vamshi</a:t>
             </a:r>
           </a:p>
         </p:txBody>

</xml_diff>